<commit_message>
enrichissement .gitignore et correction présentation
</commit_message>
<xml_diff>
--- a/Bloc3_walmart.pptx
+++ b/Bloc3_walmart.pptx
@@ -269,7 +269,7 @@
       <p15:sldGuideLst xmlns:p15="http://schemas.microsoft.com/office/powerpoint/2012/main"/>
     </p:ext>
     <p:ext uri="GoogleSlidesCustomDataVersion2">
-      <go:slidesCustomData xmlns:go="http://customooxmlschemas.google.com/" xmlns:ahyp="http://schemas.microsoft.com/office/drawing/2018/hyperlinkcolor" xmlns:p15="http://schemas.microsoft.com/office/powerpoint/2012/main" xmlns:p14="http://schemas.microsoft.com/office/powerpoint/2010/main" xmlns:com="http://schemas.openxmlformats.org/drawingml/2006/compatibility" xmlns:pvml="urn:schemas-microsoft-com:office:powerpoint" xmlns:v="urn:schemas-microsoft-com:vml" xmlns:o="urn:schemas-microsoft-com:office:office" xmlns:dgm="http://schemas.openxmlformats.org/drawingml/2006/diagram" xmlns:c="http://schemas.openxmlformats.org/drawingml/2006/chart" xmlns:mv="urn:schemas-microsoft-com:mac:vml" xmlns:mc="http://schemas.openxmlformats.org/markup-compatibility/2006" xmlns="" r:id="rId21" roundtripDataSignature="AMtx7mjRpKbBYb5zYLMrPNMhoHya77bVnQ=="/>
+      <go:slidesCustomData xmlns="" xmlns:mc="http://schemas.openxmlformats.org/markup-compatibility/2006" xmlns:mv="urn:schemas-microsoft-com:mac:vml" xmlns:c="http://schemas.openxmlformats.org/drawingml/2006/chart" xmlns:dgm="http://schemas.openxmlformats.org/drawingml/2006/diagram" xmlns:o="urn:schemas-microsoft-com:office:office" xmlns:v="urn:schemas-microsoft-com:vml" xmlns:pvml="urn:schemas-microsoft-com:office:powerpoint" xmlns:com="http://schemas.openxmlformats.org/drawingml/2006/compatibility" xmlns:p14="http://schemas.microsoft.com/office/powerpoint/2010/main" xmlns:p15="http://schemas.microsoft.com/office/powerpoint/2012/main" xmlns:ahyp="http://schemas.microsoft.com/office/drawing/2018/hyperlinkcolor" xmlns:go="http://customooxmlschemas.google.com/" r:id="rId21" roundtripDataSignature="AMtx7mjRpKbBYb5zYLMrPNMhoHya77bVnQ=="/>
     </p:ext>
   </p:extLst>
 </p:presentation>
@@ -18021,8 +18021,8 @@
         </p:nvSpPr>
         <p:spPr>
           <a:xfrm>
-            <a:off x="3865756" y="4345127"/>
-            <a:ext cx="5226205" cy="523220"/>
+            <a:off x="132888" y="4454038"/>
+            <a:ext cx="8898673" cy="307777"/>
           </a:xfrm>
           <a:prstGeom prst="rect">
             <a:avLst/>
@@ -19569,8 +19569,8 @@
               </p:nvSpPr>
               <p:spPr>
                 <a:xfrm>
-                  <a:off x="401444" y="1743189"/>
-                  <a:ext cx="2163336" cy="830997"/>
+                  <a:off x="485424" y="1485128"/>
+                  <a:ext cx="2163336" cy="1231106"/>
                 </a:xfrm>
                 <a:prstGeom prst="rect">
                   <a:avLst/>
@@ -19589,7 +19589,17 @@
                   </a:pPr>
                   <a:r>
                     <a:rPr lang="fr-FR" sz="1200" dirty="0"/>
-                    <a:t>La variable « Store » explique une part importante des variations observées</a:t>
+                    <a:t>Les ventes varient fortement selon le magasin observé</a:t>
+                  </a:r>
+                </a:p>
+                <a:p>
+                  <a:pPr marL="171450" indent="-171450">
+                    <a:buFontTx/>
+                    <a:buChar char="-"/>
+                  </a:pPr>
+                  <a:r>
+                    <a:rPr lang="fr-FR" sz="1200" dirty="0"/>
+                    <a:t>Store capte des différences structurelles entre points de vente</a:t>
                   </a:r>
                 </a:p>
               </p:txBody>
@@ -19609,8 +19619,8 @@
             </p:nvSpPr>
             <p:spPr>
               <a:xfrm>
-                <a:off x="398924" y="1382751"/>
-                <a:ext cx="2227786" cy="430887"/>
+                <a:off x="383458" y="1267565"/>
+                <a:ext cx="1820733" cy="261610"/>
               </a:xfrm>
               <a:prstGeom prst="rect">
                 <a:avLst/>
@@ -19626,7 +19636,7 @@
                 <a:pPr algn="ctr"/>
                 <a:r>
                   <a:rPr lang="fr-FR" sz="1100" b="1" dirty="0"/>
-                  <a:t>Les magasins sont le principal facteur explicatif</a:t>
+                  <a:t>Un fort effet magasin</a:t>
                 </a:r>
               </a:p>
             </p:txBody>
@@ -19646,7 +19656,7 @@
           </p:nvSpPr>
           <p:spPr>
             <a:xfrm>
-              <a:off x="1072784" y="2860412"/>
+              <a:off x="1072784" y="3009093"/>
               <a:ext cx="2163336" cy="461665"/>
             </a:xfrm>
             <a:prstGeom prst="rect">
@@ -19685,7 +19695,7 @@
           </p:nvSpPr>
           <p:spPr>
             <a:xfrm>
-              <a:off x="1070264" y="2638622"/>
+              <a:off x="1070264" y="2787303"/>
               <a:ext cx="2227786" cy="261610"/>
             </a:xfrm>
             <a:prstGeom prst="rect">
@@ -19720,7 +19730,7 @@
           </p:nvSpPr>
           <p:spPr>
             <a:xfrm>
-              <a:off x="1018793" y="3781235"/>
+              <a:off x="1018793" y="3929916"/>
               <a:ext cx="2163336" cy="646331"/>
             </a:xfrm>
             <a:prstGeom prst="rect">
@@ -19764,7 +19774,7 @@
           </p:nvSpPr>
           <p:spPr>
             <a:xfrm>
-              <a:off x="907596" y="3375856"/>
+              <a:off x="907596" y="3524537"/>
               <a:ext cx="2349190" cy="430887"/>
             </a:xfrm>
             <a:prstGeom prst="rect">
@@ -19970,10 +19980,10 @@
           </p:nvGrpSpPr>
           <p:grpSpPr>
             <a:xfrm>
-              <a:off x="3500556" y="1559464"/>
-              <a:ext cx="2163336" cy="802006"/>
-              <a:chOff x="3500556" y="1559464"/>
-              <a:chExt cx="2163336" cy="802006"/>
+              <a:off x="3500556" y="2422917"/>
+              <a:ext cx="2163336" cy="696829"/>
+              <a:chOff x="3500556" y="2422917"/>
+              <a:chExt cx="2163336" cy="696829"/>
             </a:xfrm>
           </p:grpSpPr>
           <p:sp>
@@ -19990,7 +20000,7 @@
             </p:nvSpPr>
             <p:spPr>
               <a:xfrm>
-                <a:off x="3500556" y="1899805"/>
+                <a:off x="3500556" y="2658081"/>
                 <a:ext cx="2163336" cy="461665"/>
               </a:xfrm>
               <a:prstGeom prst="rect">
@@ -20029,7 +20039,7 @@
             </p:nvSpPr>
             <p:spPr>
               <a:xfrm>
-                <a:off x="3648624" y="1559464"/>
+                <a:off x="3731327" y="2422917"/>
                 <a:ext cx="1867199" cy="261610"/>
               </a:xfrm>
               <a:prstGeom prst="rect">
@@ -20065,10 +20075,10 @@
           </p:nvGrpSpPr>
           <p:grpSpPr>
             <a:xfrm>
-              <a:off x="3494049" y="2507817"/>
-              <a:ext cx="2163336" cy="840325"/>
-              <a:chOff x="3500556" y="1705811"/>
-              <a:chExt cx="2163336" cy="840325"/>
+              <a:off x="3494049" y="3125253"/>
+              <a:ext cx="2178205" cy="862221"/>
+              <a:chOff x="3500556" y="2323247"/>
+              <a:chExt cx="2178205" cy="862221"/>
             </a:xfrm>
           </p:grpSpPr>
           <p:sp>
@@ -20085,7 +20095,7 @@
             </p:nvSpPr>
             <p:spPr>
               <a:xfrm>
-                <a:off x="3500556" y="1899805"/>
+                <a:off x="3500556" y="2539137"/>
                 <a:ext cx="2163336" cy="646331"/>
               </a:xfrm>
               <a:prstGeom prst="rect">
@@ -20124,7 +20134,7 @@
             </p:nvSpPr>
             <p:spPr>
               <a:xfrm>
-                <a:off x="3605586" y="1705811"/>
+                <a:off x="3737834" y="2323247"/>
                 <a:ext cx="1940927" cy="261610"/>
               </a:xfrm>
               <a:prstGeom prst="rect">
@@ -20160,9 +20170,9 @@
           </p:nvGrpSpPr>
           <p:grpSpPr>
             <a:xfrm>
-              <a:off x="3487875" y="3522781"/>
+              <a:off x="3487875" y="3953961"/>
               <a:ext cx="2267122" cy="670384"/>
-              <a:chOff x="3500556" y="1691086"/>
+              <a:chOff x="3500556" y="2122266"/>
               <a:chExt cx="2267122" cy="670384"/>
             </a:xfrm>
           </p:grpSpPr>
@@ -20180,7 +20190,7 @@
             </p:nvSpPr>
             <p:spPr>
               <a:xfrm>
-                <a:off x="3500556" y="1899805"/>
+                <a:off x="3500556" y="2330985"/>
                 <a:ext cx="2163336" cy="461665"/>
               </a:xfrm>
               <a:prstGeom prst="rect">
@@ -20219,7 +20229,7 @@
             </p:nvSpPr>
             <p:spPr>
               <a:xfrm>
-                <a:off x="3508959" y="1691086"/>
+                <a:off x="3508959" y="2122266"/>
                 <a:ext cx="2258719" cy="261610"/>
               </a:xfrm>
               <a:prstGeom prst="rect">
@@ -20425,10 +20435,10 @@
           </p:nvGrpSpPr>
           <p:grpSpPr>
             <a:xfrm>
-              <a:off x="5997814" y="1557809"/>
-              <a:ext cx="2163336" cy="802006"/>
-              <a:chOff x="3500556" y="1559464"/>
-              <a:chExt cx="2163336" cy="802006"/>
+              <a:off x="5991307" y="1386826"/>
+              <a:ext cx="2163336" cy="649836"/>
+              <a:chOff x="3494049" y="1388481"/>
+              <a:chExt cx="2163336" cy="649836"/>
             </a:xfrm>
           </p:grpSpPr>
           <p:sp>
@@ -20445,7 +20455,7 @@
             </p:nvSpPr>
             <p:spPr>
               <a:xfrm>
-                <a:off x="3500556" y="1899805"/>
+                <a:off x="3494049" y="1576652"/>
                 <a:ext cx="2163336" cy="461665"/>
               </a:xfrm>
               <a:prstGeom prst="rect">
@@ -20484,7 +20494,7 @@
             </p:nvSpPr>
             <p:spPr>
               <a:xfrm>
-                <a:off x="3648624" y="1559464"/>
+                <a:off x="3648624" y="1388481"/>
                 <a:ext cx="1867199" cy="261610"/>
               </a:xfrm>
               <a:prstGeom prst="rect">
@@ -20520,9 +20530,9 @@
           </p:nvGrpSpPr>
           <p:grpSpPr>
             <a:xfrm>
-              <a:off x="5991307" y="2480681"/>
+              <a:off x="5991307" y="2822651"/>
               <a:ext cx="2169843" cy="1057442"/>
-              <a:chOff x="3494049" y="1673360"/>
+              <a:chOff x="3494049" y="2015330"/>
               <a:chExt cx="2169843" cy="1057442"/>
             </a:xfrm>
           </p:grpSpPr>
@@ -20540,7 +20550,7 @@
             </p:nvSpPr>
             <p:spPr>
               <a:xfrm>
-                <a:off x="3500556" y="1899805"/>
+                <a:off x="3500556" y="2241775"/>
                 <a:ext cx="2163336" cy="830997"/>
               </a:xfrm>
               <a:prstGeom prst="rect">
@@ -20579,7 +20589,7 @@
             </p:nvSpPr>
             <p:spPr>
               <a:xfrm>
-                <a:off x="3494049" y="1673360"/>
+                <a:off x="3494049" y="2015330"/>
                 <a:ext cx="2166409" cy="261610"/>
               </a:xfrm>
               <a:prstGeom prst="rect">
@@ -20615,9 +20625,9 @@
           </p:nvGrpSpPr>
           <p:grpSpPr>
             <a:xfrm>
-              <a:off x="5994380" y="3519625"/>
+              <a:off x="5994380" y="3861595"/>
               <a:ext cx="2165857" cy="853423"/>
-              <a:chOff x="3498035" y="1692713"/>
+              <a:chOff x="3498035" y="2034683"/>
               <a:chExt cx="2165857" cy="853423"/>
             </a:xfrm>
           </p:grpSpPr>
@@ -20635,7 +20645,7 @@
             </p:nvSpPr>
             <p:spPr>
               <a:xfrm>
-                <a:off x="3500556" y="1899805"/>
+                <a:off x="3500556" y="2241775"/>
                 <a:ext cx="2163336" cy="646331"/>
               </a:xfrm>
               <a:prstGeom prst="rect">
@@ -20679,7 +20689,7 @@
             </p:nvSpPr>
             <p:spPr>
               <a:xfrm>
-                <a:off x="3498035" y="1692713"/>
+                <a:off x="3498035" y="2034683"/>
                 <a:ext cx="2163336" cy="261610"/>
               </a:xfrm>
               <a:prstGeom prst="rect">
@@ -20818,6 +20828,154 @@
           </p:txBody>
         </p:sp>
       </p:grpSp>
+      <p:sp>
+        <p:nvSpPr>
+          <p:cNvPr id="17" name="ZoneTexte 16">
+            <a:extLst>
+              <a:ext uri="{FF2B5EF4-FFF2-40B4-BE49-F238E27FC236}">
+                <a16:creationId xmlns:a16="http://schemas.microsoft.com/office/drawing/2014/main" id="{DE11FE72-8969-C04F-A051-95F542A8FB06}"/>
+              </a:ext>
+            </a:extLst>
+          </p:cNvPr>
+          <p:cNvSpPr txBox="1"/>
+          <p:nvPr/>
+        </p:nvSpPr>
+        <p:spPr>
+          <a:xfrm>
+            <a:off x="3543969" y="1359897"/>
+            <a:ext cx="2163336" cy="830997"/>
+          </a:xfrm>
+          <a:prstGeom prst="rect">
+            <a:avLst/>
+          </a:prstGeom>
+          <a:noFill/>
+        </p:spPr>
+        <p:txBody>
+          <a:bodyPr wrap="square" rtlCol="0">
+            <a:spAutoFit/>
+          </a:bodyPr>
+          <a:lstStyle/>
+          <a:p>
+            <a:pPr marL="171450" indent="-171450">
+              <a:buFontTx/>
+              <a:buChar char="-"/>
+            </a:pPr>
+            <a:r>
+              <a:rPr lang="fr-FR" sz="1200" dirty="0"/>
+              <a:t>Le modèle distingue les magasins, mais n’explique pas les causes de ces écarts</a:t>
+            </a:r>
+          </a:p>
+        </p:txBody>
+      </p:sp>
+      <p:sp>
+        <p:nvSpPr>
+          <p:cNvPr id="19" name="ZoneTexte 18">
+            <a:extLst>
+              <a:ext uri="{FF2B5EF4-FFF2-40B4-BE49-F238E27FC236}">
+                <a16:creationId xmlns:a16="http://schemas.microsoft.com/office/drawing/2014/main" id="{4E7AE900-84BA-C6E5-BC3D-B7B76DADFB03}"/>
+              </a:ext>
+            </a:extLst>
+          </p:cNvPr>
+          <p:cNvSpPr txBox="1"/>
+          <p:nvPr/>
+        </p:nvSpPr>
+        <p:spPr>
+          <a:xfrm>
+            <a:off x="3731327" y="1174751"/>
+            <a:ext cx="1867199" cy="261610"/>
+          </a:xfrm>
+          <a:prstGeom prst="rect">
+            <a:avLst/>
+          </a:prstGeom>
+          <a:noFill/>
+        </p:spPr>
+        <p:txBody>
+          <a:bodyPr wrap="square" rtlCol="0">
+            <a:spAutoFit/>
+          </a:bodyPr>
+          <a:lstStyle/>
+          <a:p>
+            <a:r>
+              <a:rPr lang="fr-FR" sz="1100" b="1" dirty="0"/>
+              <a:t>Store reste un proxy</a:t>
+            </a:r>
+          </a:p>
+        </p:txBody>
+      </p:sp>
+      <p:sp>
+        <p:nvSpPr>
+          <p:cNvPr id="25" name="ZoneTexte 24">
+            <a:extLst>
+              <a:ext uri="{FF2B5EF4-FFF2-40B4-BE49-F238E27FC236}">
+                <a16:creationId xmlns:a16="http://schemas.microsoft.com/office/drawing/2014/main" id="{D2FD37B1-CF46-595F-8D23-15961B843E53}"/>
+              </a:ext>
+            </a:extLst>
+          </p:cNvPr>
+          <p:cNvSpPr txBox="1"/>
+          <p:nvPr/>
+        </p:nvSpPr>
+        <p:spPr>
+          <a:xfrm>
+            <a:off x="5997814" y="1953090"/>
+            <a:ext cx="2163336" cy="646331"/>
+          </a:xfrm>
+          <a:prstGeom prst="rect">
+            <a:avLst/>
+          </a:prstGeom>
+          <a:noFill/>
+        </p:spPr>
+        <p:txBody>
+          <a:bodyPr wrap="square" rtlCol="0">
+            <a:spAutoFit/>
+          </a:bodyPr>
+          <a:lstStyle/>
+          <a:p>
+            <a:pPr marL="171450" indent="-171450">
+              <a:buFontTx/>
+              <a:buChar char="-"/>
+            </a:pPr>
+            <a:r>
+              <a:rPr lang="fr-FR" sz="1200" dirty="0"/>
+              <a:t>Ajouter surface, localisation, typologie, fréquentations, etc.</a:t>
+            </a:r>
+          </a:p>
+        </p:txBody>
+      </p:sp>
+      <p:sp>
+        <p:nvSpPr>
+          <p:cNvPr id="52" name="ZoneTexte 51">
+            <a:extLst>
+              <a:ext uri="{FF2B5EF4-FFF2-40B4-BE49-F238E27FC236}">
+                <a16:creationId xmlns:a16="http://schemas.microsoft.com/office/drawing/2014/main" id="{7C1BA5D6-9AB0-28BF-3D41-9C861A56C080}"/>
+              </a:ext>
+            </a:extLst>
+          </p:cNvPr>
+          <p:cNvSpPr txBox="1"/>
+          <p:nvPr/>
+        </p:nvSpPr>
+        <p:spPr>
+          <a:xfrm>
+            <a:off x="5932448" y="1764919"/>
+            <a:ext cx="2327505" cy="261610"/>
+          </a:xfrm>
+          <a:prstGeom prst="rect">
+            <a:avLst/>
+          </a:prstGeom>
+          <a:noFill/>
+        </p:spPr>
+        <p:txBody>
+          <a:bodyPr wrap="square" rtlCol="0">
+            <a:spAutoFit/>
+          </a:bodyPr>
+          <a:lstStyle/>
+          <a:p>
+            <a:r>
+              <a:rPr lang="fr-FR" sz="1100" b="1" dirty="0"/>
+              <a:t>Enrichir les données magasins</a:t>
+            </a:r>
+          </a:p>
+        </p:txBody>
+      </p:sp>
     </p:spTree>
   </p:cSld>
   <p:clrMapOvr>

</xml_diff>

<commit_message>
corrections présentation, interprétations notebook et README
</commit_message>
<xml_diff>
--- a/Bloc3_walmart.pptx
+++ b/Bloc3_walmart.pptx
@@ -18758,7 +18758,7 @@
         <p:spPr>
           <a:xfrm>
             <a:off x="5576785" y="1427356"/>
-            <a:ext cx="3577440" cy="2462213"/>
+            <a:ext cx="3577440" cy="2893100"/>
           </a:xfrm>
           <a:prstGeom prst="rect">
             <a:avLst/>
@@ -18783,7 +18783,7 @@
           <a:p>
             <a:r>
               <a:rPr lang="fr-FR" dirty="0"/>
-              <a:t>Les différences de ventes entre magasins restent le signal le plus fort du modèle.</a:t>
+              <a:t>Les différences de ventes entre magasins restent le signal le plus fort du modèle. Cependant, cela n’explique par les raisons de ces écarts.</a:t>
             </a:r>
           </a:p>
           <a:p>

</xml_diff>